<commit_message>
Mobile deck: correct the AI claims - credit the team's work and own the wrong diagnosis
</commit_message>
<xml_diff>
--- a/presentations/Mobile_Test_Automation_Appium.pptx
+++ b/presentations/Mobile_Test_Automation_Appium.pptx
@@ -4164,7 +4164,7 @@
         <p:spPr>
           <a:xfrm>
             <a:off x="566928" y="5925312"/>
-            <a:ext cx="11057839" cy="274320"/>
+            <a:ext cx="11057839" cy="365760"/>
           </a:xfrm>
           <a:prstGeom prst="rect">
             <a:avLst/>
@@ -4188,7 +4188,7 @@
                 <a:ea typeface="Segoe UI" pitchFamily="34" charset="-122"/>
                 <a:cs typeface="Segoe UI" pitchFamily="34" charset="-120"/>
               </a:rPr>
-              <a:t>"By hand" is an estimate built from those five lines. "With the agent" was measured during the session.</a:t>
+              <a:t>"By hand" is an estimate built from those five lines. "With the agent" was measured during the session - and excludes the team’s own time: adding the test ids to the app, reviewing the code and deploying it.</a:t>
             </a:r>
             <a:endParaRPr lang="en-US" sz="1150" dirty="0"/>
           </a:p>
@@ -4333,7 +4333,7 @@
         <p:spPr>
           <a:xfrm>
             <a:off x="566928" y="1627632"/>
-            <a:ext cx="2572436" cy="3703320"/>
+            <a:ext cx="2572436" cy="3886200"/>
           </a:xfrm>
           <a:prstGeom prst="roundRect">
             <a:avLst>
@@ -4409,7 +4409,7 @@
                 <a:ea typeface="Segoe UI" pitchFamily="34" charset="-122"/>
                 <a:cs typeface="Segoe UI" pitchFamily="34" charset="-120"/>
               </a:rPr>
-              <a:t>1. It read the app to find the truth</a:t>
+              <a:t>1. It read the app instead of guessing</a:t>
             </a:r>
             <a:endParaRPr lang="en-US" sz="1450" dirty="0"/>
           </a:p>
@@ -4448,7 +4448,7 @@
                 <a:ea typeface="Segoe UI" pitchFamily="34" charset="-122"/>
                 <a:cs typeface="Segoe UI" pitchFamily="34" charset="-120"/>
               </a:rPr>
-              <a:t>Not trial and error.</a:t>
+              <a:t>After the first failure, not before.</a:t>
             </a:r>
             <a:endParaRPr lang="en-US" sz="1200" dirty="0"/>
           </a:p>
@@ -4463,7 +4463,7 @@
         <p:spPr>
           <a:xfrm>
             <a:off x="768096" y="3090672"/>
-            <a:ext cx="2170100" cy="2103120"/>
+            <a:ext cx="2170100" cy="2286000"/>
           </a:xfrm>
           <a:prstGeom prst="rect">
             <a:avLst/>
@@ -4491,7 +4491,7 @@
                 <a:ea typeface="Segoe UI" pitchFamily="34" charset="-122"/>
                 <a:cs typeface="Segoe UI" pitchFamily="34" charset="-120"/>
               </a:rPr>
-              <a:t>The phone number must be exactly 10 digits - a rule buried in the app’s code</a:t>
+              <a:t>Tapping Sign In did nothing - the phone number must be exactly 10 digits, a rule buried in the code</a:t>
             </a:r>
             <a:endParaRPr lang="en-US" sz="1200" dirty="0"/>
           </a:p>
@@ -4512,7 +4512,7 @@
                 <a:ea typeface="Segoe UI" pitchFamily="34" charset="-122"/>
                 <a:cs typeface="Segoe UI" pitchFamily="34" charset="-120"/>
               </a:rPr>
-              <a:t>Get it wrong and the button silently does nothing, which is a long afternoon of confusion</a:t>
+              <a:t>It found that rule instead of trying numbers until one worked</a:t>
             </a:r>
             <a:endParaRPr lang="en-US" sz="1200" dirty="0"/>
           </a:p>
@@ -4533,7 +4533,7 @@
                 <a:ea typeface="Segoe UI" pitchFamily="34" charset="-122"/>
                 <a:cs typeface="Segoe UI" pitchFamily="34" charset="-120"/>
               </a:rPr>
-              <a:t>It found the rule, and made the test say so out loud</a:t>
+              <a:t>The test now fails in a second, with a clear reason</a:t>
             </a:r>
             <a:endParaRPr lang="en-US" sz="1200" dirty="0"/>
           </a:p>
@@ -4548,7 +4548,7 @@
         <p:spPr>
           <a:xfrm>
             <a:off x="3395396" y="1627632"/>
-            <a:ext cx="2572436" cy="3703320"/>
+            <a:ext cx="2572436" cy="3886200"/>
           </a:xfrm>
           <a:prstGeom prst="roundRect">
             <a:avLst>
@@ -4624,7 +4624,7 @@
                 <a:ea typeface="Segoe UI" pitchFamily="34" charset="-122"/>
                 <a:cs typeface="Segoe UI" pitchFamily="34" charset="-120"/>
               </a:rPr>
-              <a:t>2. It worked across three systems at once</a:t>
+              <a:t>2. One agent, three languages</a:t>
             </a:r>
             <a:endParaRPr lang="en-US" sz="1450" dirty="0"/>
           </a:p>
@@ -4663,7 +4663,7 @@
                 <a:ea typeface="Segoe UI" pitchFamily="34" charset="-122"/>
                 <a:cs typeface="Segoe UI" pitchFamily="34" charset="-120"/>
               </a:rPr>
-              <a:t>App, backend and test suite together.</a:t>
+              <a:t>Android app, backend, tests.</a:t>
             </a:r>
             <a:endParaRPr lang="en-US" sz="1200" dirty="0"/>
           </a:p>
@@ -4678,7 +4678,7 @@
         <p:spPr>
           <a:xfrm>
             <a:off x="3596564" y="3090672"/>
-            <a:ext cx="2170100" cy="2103120"/>
+            <a:ext cx="2170100" cy="2286000"/>
           </a:xfrm>
           <a:prstGeom prst="rect">
             <a:avLst/>
@@ -4706,7 +4706,7 @@
                 <a:ea typeface="Segoe UI" pitchFamily="34" charset="-122"/>
                 <a:cs typeface="Segoe UI" pitchFamily="34" charset="-120"/>
               </a:rPr>
-              <a:t>The OTP fix needed a change in the RoadSide backend, a deploy, and a helper in the test</a:t>
+              <a:t>Reading the login meant Kotlin; the endpoint that reads the SMS back meant C#; the test meant TypeScript</a:t>
             </a:r>
             <a:endParaRPr lang="en-US" sz="1200" dirty="0"/>
           </a:p>
@@ -4727,7 +4727,7 @@
                 <a:ea typeface="Segoe UI" pitchFamily="34" charset="-122"/>
                 <a:cs typeface="Segoe UI" pitchFamily="34" charset="-120"/>
               </a:rPr>
-              <a:t>Normally three people, three tickets and a week of waiting on each other</a:t>
+              <a:t>No handover between people, and nobody waiting to be told what the other half does</a:t>
             </a:r>
             <a:endParaRPr lang="en-US" sz="1200" dirty="0"/>
           </a:p>
@@ -4742,7 +4742,7 @@
         <p:spPr>
           <a:xfrm>
             <a:off x="6223864" y="1627632"/>
-            <a:ext cx="2572436" cy="3703320"/>
+            <a:ext cx="2572436" cy="3886200"/>
           </a:xfrm>
           <a:prstGeom prst="roundRect">
             <a:avLst>
@@ -4818,7 +4818,7 @@
                 <a:ea typeface="Segoe UI" pitchFamily="34" charset="-122"/>
                 <a:cs typeface="Segoe UI" pitchFamily="34" charset="-120"/>
               </a:rPr>
-              <a:t>3. It debugged what looked hopeless</a:t>
+              <a:t>3. It kept testing until it was right</a:t>
             </a:r>
             <a:endParaRPr lang="en-US" sz="1450" dirty="0"/>
           </a:p>
@@ -4857,7 +4857,7 @@
                 <a:ea typeface="Segoe UI" pitchFamily="34" charset="-122"/>
                 <a:cs typeface="Segoe UI" pitchFamily="34" charset="-120"/>
               </a:rPr>
-              <a:t>"The emulator has no internet."</a:t>
+              <a:t>It got this one wrong first.</a:t>
             </a:r>
             <a:endParaRPr lang="en-US" sz="1200" dirty="0"/>
           </a:p>
@@ -4872,7 +4872,7 @@
         <p:spPr>
           <a:xfrm>
             <a:off x="6425032" y="3090672"/>
-            <a:ext cx="2170100" cy="2103120"/>
+            <a:ext cx="2170100" cy="2286000"/>
           </a:xfrm>
           <a:prstGeom prst="rect">
             <a:avLst/>
@@ -4900,7 +4900,7 @@
                 <a:ea typeface="Segoe UI" pitchFamily="34" charset="-122"/>
                 <a:cs typeface="Segoe UI" pitchFamily="34" charset="-120"/>
               </a:rPr>
-              <a:t>It checked what actually worked and what did not, and proved only name lookup was blocked</a:t>
+              <a:t>It said the emulator’s network card was dead and suggested using a real phone. That was wrong</a:t>
             </a:r>
             <a:endParaRPr lang="en-US" sz="1200" dirty="0"/>
           </a:p>
@@ -4921,10 +4921,31 @@
                 <a:ea typeface="Segoe UI" pitchFamily="34" charset="-122"/>
                 <a:cs typeface="Segoe UI" pitchFamily="34" charset="-120"/>
               </a:rPr>
-              <a:t>Then it built the small workaround that fixed it - about an hour, instead of giving up and buying handsets</a:t>
+              <a:t>It went back, proved only name lookup was blocked, and fixed it in about an hour</a:t>
             </a:r>
             <a:endParaRPr lang="en-US" sz="1200" dirty="0"/>
           </a:p>
+          <a:p>
+            <a:pPr marL="342900" indent="-342900">
+              <a:spcAft>
+                <a:spcPts val="600"/>
+              </a:spcAft>
+              <a:buSzPct val="100000"/>
+              <a:buChar char="•"/>
+            </a:pPr>
+            <a:r>
+              <a:rPr lang="en-US" sz="1200" dirty="0">
+                <a:solidFill>
+                  <a:srgbClr val="3F3F46"/>
+                </a:solidFill>
+                <a:latin typeface="Segoe UI" pitchFamily="34" charset="0"/>
+                <a:ea typeface="Segoe UI" pitchFamily="34" charset="-122"/>
+                <a:cs typeface="Segoe UI" pitchFamily="34" charset="-120"/>
+              </a:rPr>
+              <a:t>Fast at trying things - not immune to being wrong</a:t>
+            </a:r>
+            <a:endParaRPr lang="en-US" sz="1200" dirty="0"/>
+          </a:p>
         </p:txBody>
       </p:sp>
       <p:sp>
@@ -4936,7 +4957,7 @@
         <p:spPr>
           <a:xfrm>
             <a:off x="9052331" y="1627632"/>
-            <a:ext cx="2572436" cy="3703320"/>
+            <a:ext cx="2572436" cy="3886200"/>
           </a:xfrm>
           <a:prstGeom prst="roundRect">
             <a:avLst>
@@ -5066,7 +5087,7 @@
         <p:spPr>
           <a:xfrm>
             <a:off x="9253499" y="3090672"/>
-            <a:ext cx="2170100" cy="2103120"/>
+            <a:ext cx="2170100" cy="2286000"/>
           </a:xfrm>
           <a:prstGeom prst="rect">
             <a:avLst/>
@@ -5094,7 +5115,7 @@
                 <a:ea typeface="Segoe UI" pitchFamily="34" charset="-122"/>
                 <a:cs typeface="Segoe UI" pitchFamily="34" charset="-120"/>
               </a:rPr>
-              <a:t>Every dead end went into the README while it was fresh</a:t>
+              <a:t>Every dead end went into the README while it was fresh - including the wrong turn above</a:t>
             </a:r>
             <a:endParaRPr lang="en-US" sz="1200" dirty="0"/>
           </a:p>
@@ -5115,7 +5136,7 @@
                 <a:ea typeface="Segoe UI" pitchFamily="34" charset="-122"/>
                 <a:cs typeface="Segoe UI" pitchFamily="34" charset="-120"/>
               </a:rPr>
-              <a:t>The next person does not repeat the same day of trial and error</a:t>
+              <a:t>The next person does not lose the same afternoon</a:t>
             </a:r>
             <a:endParaRPr lang="en-US" sz="1200" dirty="0"/>
           </a:p>
@@ -5129,12 +5150,12 @@
         </p:nvSpPr>
         <p:spPr>
           <a:xfrm>
-            <a:off x="566928" y="5559552"/>
-            <a:ext cx="11057839" cy="685800"/>
+            <a:off x="566928" y="5696712"/>
+            <a:ext cx="11057839" cy="658368"/>
           </a:xfrm>
           <a:prstGeom prst="roundRect">
             <a:avLst>
-              <a:gd name="adj" fmla="val 8000"/>
+              <a:gd name="adj" fmla="val 8333"/>
             </a:avLst>
           </a:prstGeom>
           <a:solidFill>
@@ -5156,8 +5177,8 @@
         </p:nvSpPr>
         <p:spPr>
           <a:xfrm>
-            <a:off x="566928" y="5559552"/>
-            <a:ext cx="64008" cy="685800"/>
+            <a:off x="566928" y="5696712"/>
+            <a:ext cx="64008" cy="658368"/>
           </a:xfrm>
           <a:prstGeom prst="rect">
             <a:avLst/>
@@ -5181,8 +5202,8 @@
         </p:nvSpPr>
         <p:spPr>
           <a:xfrm>
-            <a:off x="822960" y="5559552"/>
-            <a:ext cx="10600639" cy="685800"/>
+            <a:off x="822960" y="5696712"/>
+            <a:ext cx="10600639" cy="658368"/>
           </a:xfrm>
           <a:prstGeom prst="rect">
             <a:avLst/>
@@ -5206,7 +5227,7 @@
                 <a:ea typeface="Segoe UI" pitchFamily="34" charset="-122"/>
                 <a:cs typeface="Segoe UI" pitchFamily="34" charset="-120"/>
               </a:rPr>
-              <a:t>Put simply: a person is fast at deciding what matters and slow at everything around it. The agent is the other way round - which is why the pair is quicker than either alone.</a:t>
+              <a:t>The honest split: the test ids in the app, the code review and every deploy were done by the team. The agent wrote the tests, the backend endpoint and the debugging - and was still the fastest part of the day.</a:t>
             </a:r>
             <a:endParaRPr lang="en-US" sz="1350" dirty="0"/>
           </a:p>

</xml_diff>

<commit_message>
Decks: make Why it is faster a shared, general slide in both
</commit_message>
<xml_diff>
--- a/presentations/Mobile_Test_Automation_Appium.pptx
+++ b/presentations/Mobile_Test_Automation_Appium.pptx
@@ -4409,7 +4409,7 @@
                 <a:ea typeface="Segoe UI" pitchFamily="34" charset="-122"/>
                 <a:cs typeface="Segoe UI" pitchFamily="34" charset="-120"/>
               </a:rPr>
-              <a:t>1. It read the app instead of guessing</a:t>
+              <a:t>1. It reads the whole system at once</a:t>
             </a:r>
             <a:endParaRPr lang="en-US" sz="1450" dirty="0"/>
           </a:p>
@@ -4448,7 +4448,7 @@
                 <a:ea typeface="Segoe UI" pitchFamily="34" charset="-122"/>
                 <a:cs typeface="Segoe UI" pitchFamily="34" charset="-120"/>
               </a:rPr>
-              <a:t>After the first failure, not before.</a:t>
+              <a:t>A person opens one file at a time.</a:t>
             </a:r>
             <a:endParaRPr lang="en-US" sz="1200" dirty="0"/>
           </a:p>
@@ -4491,7 +4491,7 @@
                 <a:ea typeface="Segoe UI" pitchFamily="34" charset="-122"/>
                 <a:cs typeface="Segoe UI" pitchFamily="34" charset="-120"/>
               </a:rPr>
-              <a:t>Tapping Sign In did nothing - the phone number must be exactly 10 digits, a rule buried in the code</a:t>
+              <a:t>To write a test you have to know exactly what each field and button is called</a:t>
             </a:r>
             <a:endParaRPr lang="en-US" sz="1200" dirty="0"/>
           </a:p>
@@ -4512,7 +4512,7 @@
                 <a:ea typeface="Segoe UI" pitchFamily="34" charset="-122"/>
                 <a:cs typeface="Segoe UI" pitchFamily="34" charset="-120"/>
               </a:rPr>
-              <a:t>It found that rule instead of trying numbers until one worked</a:t>
+              <a:t>A person clicks around and guesses, or searches the code by hand</a:t>
             </a:r>
             <a:endParaRPr lang="en-US" sz="1200" dirty="0"/>
           </a:p>
@@ -4533,7 +4533,7 @@
                 <a:ea typeface="Segoe UI" pitchFamily="34" charset="-122"/>
                 <a:cs typeface="Segoe UI" pitchFamily="34" charset="-120"/>
               </a:rPr>
-              <a:t>The test now fails in a second, with a clear reason</a:t>
+              <a:t>The agent reads the source and takes the real names straight from it</a:t>
             </a:r>
             <a:endParaRPr lang="en-US" sz="1200" dirty="0"/>
           </a:p>
@@ -4624,7 +4624,7 @@
                 <a:ea typeface="Segoe UI" pitchFamily="34" charset="-122"/>
                 <a:cs typeface="Segoe UI" pitchFamily="34" charset="-120"/>
               </a:rPr>
-              <a:t>2. One agent, three languages</a:t>
+              <a:t>2. It works without stopping</a:t>
             </a:r>
             <a:endParaRPr lang="en-US" sz="1450" dirty="0"/>
           </a:p>
@@ -4663,7 +4663,7 @@
                 <a:ea typeface="Segoe UI" pitchFamily="34" charset="-122"/>
                 <a:cs typeface="Segoe UI" pitchFamily="34" charset="-120"/>
               </a:rPr>
-              <a:t>Android app, backend, tests.</a:t>
+              <a:t>No meetings, no context switching.</a:t>
             </a:r>
             <a:endParaRPr lang="en-US" sz="1200" dirty="0"/>
           </a:p>
@@ -4706,7 +4706,7 @@
                 <a:ea typeface="Segoe UI" pitchFamily="34" charset="-122"/>
                 <a:cs typeface="Segoe UI" pitchFamily="34" charset="-120"/>
               </a:rPr>
-              <a:t>Reading the login meant Kotlin; the endpoint that reads the SMS back meant C#; the test meant TypeScript</a:t>
+              <a:t>Work like this is normally spread over days, and part of every day goes on remembering where you were</a:t>
             </a:r>
             <a:endParaRPr lang="en-US" sz="1200" dirty="0"/>
           </a:p>
@@ -4727,7 +4727,7 @@
                 <a:ea typeface="Segoe UI" pitchFamily="34" charset="-122"/>
                 <a:cs typeface="Segoe UI" pitchFamily="34" charset="-120"/>
               </a:rPr>
-              <a:t>No handover between people, and nobody waiting to be told what the other half does</a:t>
+              <a:t>The agent does it as one continuous job</a:t>
             </a:r>
             <a:endParaRPr lang="en-US" sz="1200" dirty="0"/>
           </a:p>
@@ -4818,7 +4818,7 @@
                 <a:ea typeface="Segoe UI" pitchFamily="34" charset="-122"/>
                 <a:cs typeface="Segoe UI" pitchFamily="34" charset="-120"/>
               </a:rPr>
-              <a:t>3. It kept testing until it was right</a:t>
+              <a:t>3. Try, fail, fix - in seconds</a:t>
             </a:r>
             <a:endParaRPr lang="en-US" sz="1450" dirty="0"/>
           </a:p>
@@ -4857,7 +4857,7 @@
                 <a:ea typeface="Segoe UI" pitchFamily="34" charset="-122"/>
                 <a:cs typeface="Segoe UI" pitchFamily="34" charset="-120"/>
               </a:rPr>
-              <a:t>It got this one wrong first.</a:t>
+              <a:t>That loop is where the time really goes.</a:t>
             </a:r>
             <a:endParaRPr lang="en-US" sz="1200" dirty="0"/>
           </a:p>
@@ -4900,7 +4900,7 @@
                 <a:ea typeface="Segoe UI" pitchFamily="34" charset="-122"/>
                 <a:cs typeface="Segoe UI" pitchFamily="34" charset="-120"/>
               </a:rPr>
-              <a:t>It said the emulator’s network card was dead and suggested using a real phone. That was wrong</a:t>
+              <a:t>Automation is mostly: run it, see what broke, fix it, run it again</a:t>
             </a:r>
             <a:endParaRPr lang="en-US" sz="1200" dirty="0"/>
           </a:p>
@@ -4921,28 +4921,7 @@
                 <a:ea typeface="Segoe UI" pitchFamily="34" charset="-122"/>
                 <a:cs typeface="Segoe UI" pitchFamily="34" charset="-120"/>
               </a:rPr>
-              <a:t>It went back, proved only name lookup was blocked, and fixed it in about an hour</a:t>
-            </a:r>
-            <a:endParaRPr lang="en-US" sz="1200" dirty="0"/>
-          </a:p>
-          <a:p>
-            <a:pPr marL="342900" indent="-342900">
-              <a:spcAft>
-                <a:spcPts val="600"/>
-              </a:spcAft>
-              <a:buSzPct val="100000"/>
-              <a:buChar char="•"/>
-            </a:pPr>
-            <a:r>
-              <a:rPr lang="en-US" sz="1200" dirty="0">
-                <a:solidFill>
-                  <a:srgbClr val="3F3F46"/>
-                </a:solidFill>
-                <a:latin typeface="Segoe UI" pitchFamily="34" charset="0"/>
-                <a:ea typeface="Segoe UI" pitchFamily="34" charset="-122"/>
-                <a:cs typeface="Segoe UI" pitchFamily="34" charset="-120"/>
-              </a:rPr>
-              <a:t>Fast at trying things - not immune to being wrong</a:t>
+              <a:t>For a person each turn of that loop costs minutes and patience; here it is seconds, repeated without fatigue</a:t>
             </a:r>
             <a:endParaRPr lang="en-US" sz="1200" dirty="0"/>
           </a:p>
@@ -5033,7 +5012,7 @@
                 <a:ea typeface="Segoe UI" pitchFamily="34" charset="-122"/>
                 <a:cs typeface="Segoe UI" pitchFamily="34" charset="-120"/>
               </a:rPr>
-              <a:t>4. It writes it down as it goes</a:t>
+              <a:t>4. It does the parts we skip</a:t>
             </a:r>
             <a:endParaRPr lang="en-US" sz="1450" dirty="0"/>
           </a:p>
@@ -5072,7 +5051,7 @@
                 <a:ea typeface="Segoe UI" pitchFamily="34" charset="-122"/>
                 <a:cs typeface="Segoe UI" pitchFamily="34" charset="-120"/>
               </a:rPr>
-              <a:t>Normally the last job, usually skipped.</a:t>
+              <a:t>Structure, evidence, documentation.</a:t>
             </a:r>
             <a:endParaRPr lang="en-US" sz="1200" dirty="0"/>
           </a:p>
@@ -5115,7 +5094,7 @@
                 <a:ea typeface="Segoe UI" pitchFamily="34" charset="-122"/>
                 <a:cs typeface="Segoe UI" pitchFamily="34" charset="-120"/>
               </a:rPr>
-              <a:t>Every dead end went into the README while it was fresh - including the wrong turn above</a:t>
+              <a:t>Consistent naming, a README, screenshots and reports come as standard</a:t>
             </a:r>
             <a:endParaRPr lang="en-US" sz="1200" dirty="0"/>
           </a:p>
@@ -5136,7 +5115,7 @@
                 <a:ea typeface="Segoe UI" pitchFamily="34" charset="-122"/>
                 <a:cs typeface="Segoe UI" pitchFamily="34" charset="-120"/>
               </a:rPr>
-              <a:t>The next person does not lose the same afternoon</a:t>
+              <a:t>These are the first things dropped when a deadline is close - and the reason the next person starts from nothing</a:t>
             </a:r>
             <a:endParaRPr lang="en-US" sz="1200" dirty="0"/>
           </a:p>
@@ -5227,7 +5206,7 @@
                 <a:ea typeface="Segoe UI" pitchFamily="34" charset="-122"/>
                 <a:cs typeface="Segoe UI" pitchFamily="34" charset="-120"/>
               </a:rPr>
-              <a:t>The honest split: the test ids in the app, the code review and every deploy were done by the team. The agent wrote the tests, the backend endpoint and the debugging - and was still the fastest part of the day.</a:t>
+              <a:t>A person is fast at deciding what matters. The agent is fast at everything around it. That is why the pair beats either one alone.</a:t>
             </a:r>
             <a:endParaRPr lang="en-US" sz="1350" dirty="0"/>
           </a:p>

</xml_diff>